<commit_message>
Module 7: label the API bar as the per-token bill to Anthropic or AWS
Co-Authored-By: Claude Opus 5.5 <noreply@anthropic.com>
</commit_message>
<xml_diff>
--- a/slides/Module-07-AI-Governance-Security-Cost.pptx
+++ b/slides/Module-07-AI-Governance-Security-Cost.pptx
@@ -4395,7 +4395,41 @@
       </p:sp>
       <p:sp>
         <p:nvSpPr>
-          <p:cNvPr id="18" name="Rectangle 17"/>
+          <p:cNvPr id="18" name="TextBox 17"/>
+          <p:cNvSpPr txBox="1"/>
+          <p:nvPr/>
+        </p:nvSpPr>
+        <p:spPr>
+          <a:xfrm>
+            <a:off x="804672" y="4379975"/>
+            <a:ext cx="2377440" cy="274320"/>
+          </a:xfrm>
+          <a:prstGeom prst="rect">
+            <a:avLst/>
+          </a:prstGeom>
+          <a:noFill/>
+        </p:spPr>
+        <p:txBody>
+          <a:bodyPr wrap="square" anchor="t" lIns="0" rIns="0" tIns="0" bIns="0">
+            <a:spAutoFit/>
+          </a:bodyPr>
+          <a:lstStyle/>
+          <a:p>
+            <a:pPr algn="l"/>
+            <a:r>
+              <a:rPr sz="900" b="0">
+                <a:solidFill>
+                  <a:srgbClr val="5D6B7E"/>
+                </a:solidFill>
+              </a:rPr>
+              <a:t>per-token bill to Anthropic or AWS</a:t>
+            </a:r>
+          </a:p>
+        </p:txBody>
+      </p:sp>
+      <p:sp>
+        <p:nvSpPr>
+          <p:cNvPr id="19" name="Rectangle 18"/>
           <p:cNvSpPr/>
           <p:nvPr/>
         </p:nvSpPr>
@@ -4439,7 +4473,7 @@
       </p:sp>
       <p:sp>
         <p:nvSpPr>
-          <p:cNvPr id="19" name="TextBox 18"/>
+          <p:cNvPr id="20" name="TextBox 19"/>
           <p:cNvSpPr txBox="1"/>
           <p:nvPr/>
         </p:nvSpPr>
@@ -4474,7 +4508,7 @@
       </p:sp>
       <p:sp>
         <p:nvSpPr>
-          <p:cNvPr id="20" name="TextBox 19"/>
+          <p:cNvPr id="21" name="TextBox 20"/>
           <p:cNvSpPr txBox="1"/>
           <p:nvPr/>
         </p:nvSpPr>
@@ -4509,7 +4543,7 @@
       </p:sp>
       <p:sp>
         <p:nvSpPr>
-          <p:cNvPr id="21" name="Rectangle 20"/>
+          <p:cNvPr id="22" name="Rectangle 21"/>
           <p:cNvSpPr/>
           <p:nvPr/>
         </p:nvSpPr>
@@ -4553,7 +4587,7 @@
       </p:sp>
       <p:sp>
         <p:nvSpPr>
-          <p:cNvPr id="22" name="TextBox 21"/>
+          <p:cNvPr id="23" name="TextBox 22"/>
           <p:cNvSpPr txBox="1"/>
           <p:nvPr/>
         </p:nvSpPr>
@@ -4587,7 +4621,7 @@
       </p:sp>
       <p:sp>
         <p:nvSpPr>
-          <p:cNvPr id="23" name="TextBox 22"/>
+          <p:cNvPr id="24" name="TextBox 23"/>
           <p:cNvSpPr txBox="1"/>
           <p:nvPr/>
         </p:nvSpPr>
@@ -4637,7 +4671,7 @@
       </p:sp>
       <p:sp>
         <p:nvSpPr>
-          <p:cNvPr id="24" name="TextBox 23"/>
+          <p:cNvPr id="25" name="TextBox 24"/>
           <p:cNvSpPr txBox="1"/>
           <p:nvPr/>
         </p:nvSpPr>
@@ -4687,7 +4721,7 @@
       </p:sp>
       <p:sp>
         <p:nvSpPr>
-          <p:cNvPr id="25" name="TextBox 24"/>
+          <p:cNvPr id="26" name="TextBox 25"/>
           <p:cNvSpPr txBox="1"/>
           <p:nvPr/>
         </p:nvSpPr>
@@ -4737,7 +4771,7 @@
       </p:sp>
       <p:sp>
         <p:nvSpPr>
-          <p:cNvPr id="26" name="Rectangle 25"/>
+          <p:cNvPr id="27" name="Rectangle 26"/>
           <p:cNvSpPr/>
           <p:nvPr/>
         </p:nvSpPr>
@@ -4781,7 +4815,7 @@
       </p:sp>
       <p:sp>
         <p:nvSpPr>
-          <p:cNvPr id="27" name="Rectangle 26"/>
+          <p:cNvPr id="28" name="Rectangle 27"/>
           <p:cNvSpPr/>
           <p:nvPr/>
         </p:nvSpPr>
@@ -4825,7 +4859,7 @@
       </p:sp>
       <p:sp>
         <p:nvSpPr>
-          <p:cNvPr id="28" name="TextBox 27"/>
+          <p:cNvPr id="29" name="TextBox 28"/>
           <p:cNvSpPr txBox="1"/>
           <p:nvPr/>
         </p:nvSpPr>
@@ -4867,7 +4901,7 @@
       </p:sp>
       <p:sp>
         <p:nvSpPr>
-          <p:cNvPr id="29" name="TextBox 28"/>
+          <p:cNvPr id="30" name="TextBox 29"/>
           <p:cNvSpPr txBox="1"/>
           <p:nvPr/>
         </p:nvSpPr>
@@ -4901,7 +4935,7 @@
       </p:sp>
       <p:sp>
         <p:nvSpPr>
-          <p:cNvPr id="30" name="TextBox 29"/>
+          <p:cNvPr id="31" name="TextBox 30"/>
           <p:cNvSpPr txBox="1"/>
           <p:nvPr/>
         </p:nvSpPr>

</xml_diff>

<commit_message>
Module 7 live lab: show AI usage in a working day, not governance
Co-Authored-By: Claude Opus 5.5 <noreply@anthropic.com>
</commit_message>
<xml_diff>
--- a/slides/Module-07-AI-Governance-Security-Cost.pptx
+++ b/slides/Module-07-AI-Governance-Security-Cost.pptx
@@ -12126,7 +12126,7 @@
                 </a:solidFill>
                 <a:latin typeface="Georgia"/>
               </a:rPr>
-              <a:t>The instructor shows a corporate login and the AI tools staff use every day at a large financial firm. The firm is not named. You watch, ask questions and take notes.</a:t>
+              <a:t>The instructor shows how staff at a large financial firm sign in and use AI tools in a normal working day. The firm is not named. You watch, ask questions and take notes.</a:t>
             </a:r>
           </a:p>
         </p:txBody>
@@ -12324,7 +12324,7 @@
                   <a:srgbClr val="1B2A41"/>
                 </a:solidFill>
               </a:rPr>
-              <a:t>The second check on the phone</a:t>
+              <a:t>The AI tools that open after login</a:t>
             </a:r>
           </a:p>
         </p:txBody>
@@ -12366,7 +12366,7 @@
                   <a:srgbClr val="1B2A41"/>
                 </a:solidFill>
               </a:rPr>
-              <a:t>What a leaver loses on day one</a:t>
+              <a:t>Where the AI sits: email, chat, documents</a:t>
             </a:r>
           </a:p>
         </p:txBody>
@@ -12408,7 +12408,7 @@
                   <a:srgbClr val="1B2A41"/>
                 </a:solidFill>
               </a:rPr>
-              <a:t>Why a personal email is never used</a:t>
+              <a:t>How a staff member starts a task</a:t>
             </a:r>
           </a:p>
         </p:txBody>
@@ -12648,7 +12648,7 @@
                   <a:srgbClr val="1B2A41"/>
                 </a:solidFill>
               </a:rPr>
-              <a:t>What data may go in, and what may not</a:t>
+              <a:t>Searching company documents with AI</a:t>
             </a:r>
           </a:p>
         </p:txBody>
@@ -12690,7 +12690,7 @@
                   <a:srgbClr val="1B2A41"/>
                 </a:solidFill>
               </a:rPr>
-              <a:t>Where a person checks and signs</a:t>
+              <a:t>Meeting notes and quick summaries</a:t>
             </a:r>
           </a:p>
         </p:txBody>
@@ -12888,7 +12888,7 @@
                   <a:srgbClr val="C9D6EE"/>
                 </a:solidFill>
               </a:rPr>
-              <a:t>Name one control you saw</a:t>
+              <a:t>Name one task AI made faster</a:t>
             </a:r>
           </a:p>
         </p:txBody>
@@ -12930,7 +12930,7 @@
                   <a:srgbClr val="C9D6EE"/>
                 </a:solidFill>
               </a:rPr>
-              <a:t>Name one risk you would fix</a:t>
+              <a:t>Name one task you would use it for</a:t>
             </a:r>
           </a:p>
         </p:txBody>
@@ -13104,7 +13104,7 @@
                   <a:srgbClr val="FFFFFF"/>
                 </a:solidFill>
               </a:rPr>
-              <a:t>every control on slides 2 to 18 exists in a real firm for a reason. Today you see where the human signs and what gets logged.</a:t>
+              <a:t>you see how AI is really used in a working day at a financial firm, not just on a slide.</a:t>
             </a:r>
           </a:p>
         </p:txBody>

</xml_diff>